<commit_message>
Restore Kai's original notebooks and separate contributions
</commit_message>
<xml_diff>
--- a/presentation/ap_presentation_de.pptx
+++ b/presentation/ap_presentation_de.pptx
@@ -2,25 +2,25 @@
 <file path=ppt/presentation.xml><?xml version="1.0" encoding="utf-8"?>
 <p:presentation xmlns:p="http://schemas.openxmlformats.org/presentationml/2006/main">
   <p:sldMasterIdLst>
-    <p:sldMasterId xmlns:r="http://schemas.openxmlformats.org/officeDocument/2006/relationships" id="2147483648" r:id="Rd65a41d11f4a462d"/>
+    <p:sldMasterId xmlns:r="http://schemas.openxmlformats.org/officeDocument/2006/relationships" id="2147483648" r:id="R847003a0329f4cb3"/>
   </p:sldMasterIdLst>
   <p:notesMasterIdLst>
-    <p:notesMasterId xmlns:r="http://schemas.openxmlformats.org/officeDocument/2006/relationships" r:id="Rb75a361b3b0e417c"/>
+    <p:notesMasterId xmlns:r="http://schemas.openxmlformats.org/officeDocument/2006/relationships" r:id="Ra8b659730828448f"/>
   </p:notesMasterIdLst>
   <p:sldIdLst>
-    <p:sldId xmlns:r="http://schemas.openxmlformats.org/officeDocument/2006/relationships" id="256" r:id="R0d75a5ae71c04a0f"/>
-    <p:sldId xmlns:r="http://schemas.openxmlformats.org/officeDocument/2006/relationships" id="257" r:id="Rd7116b3e121140f3"/>
-    <p:sldId xmlns:r="http://schemas.openxmlformats.org/officeDocument/2006/relationships" id="258" r:id="R319f6e4958ad4e60"/>
-    <p:sldId xmlns:r="http://schemas.openxmlformats.org/officeDocument/2006/relationships" id="259" r:id="R4747b2ca82b947ab"/>
-    <p:sldId xmlns:r="http://schemas.openxmlformats.org/officeDocument/2006/relationships" id="260" r:id="Rc3004bc7019b415f"/>
-    <p:sldId xmlns:r="http://schemas.openxmlformats.org/officeDocument/2006/relationships" id="261" r:id="Redf4a31c1e4f4be2"/>
-    <p:sldId xmlns:r="http://schemas.openxmlformats.org/officeDocument/2006/relationships" id="262" r:id="R17451ac878044bff"/>
-    <p:sldId xmlns:r="http://schemas.openxmlformats.org/officeDocument/2006/relationships" id="263" r:id="R5591c7caea684094"/>
-    <p:sldId xmlns:r="http://schemas.openxmlformats.org/officeDocument/2006/relationships" id="264" r:id="R7ef02f5930b14821"/>
-    <p:sldId xmlns:r="http://schemas.openxmlformats.org/officeDocument/2006/relationships" id="265" r:id="R9e9f603942154c08"/>
-    <p:sldId xmlns:r="http://schemas.openxmlformats.org/officeDocument/2006/relationships" id="266" r:id="R0287b6b1bb6a479b"/>
-    <p:sldId xmlns:r="http://schemas.openxmlformats.org/officeDocument/2006/relationships" id="267" r:id="R8669c108a3884e6c"/>
-    <p:sldId xmlns:r="http://schemas.openxmlformats.org/officeDocument/2006/relationships" id="268" r:id="R2c8ae5ce082c4a87"/>
+    <p:sldId xmlns:r="http://schemas.openxmlformats.org/officeDocument/2006/relationships" id="256" r:id="R4bc5fbe5ec6645df"/>
+    <p:sldId xmlns:r="http://schemas.openxmlformats.org/officeDocument/2006/relationships" id="257" r:id="Rbf3163cd58384415"/>
+    <p:sldId xmlns:r="http://schemas.openxmlformats.org/officeDocument/2006/relationships" id="258" r:id="Rcb6ab663b64a43df"/>
+    <p:sldId xmlns:r="http://schemas.openxmlformats.org/officeDocument/2006/relationships" id="259" r:id="Rf462c63b7b0342ca"/>
+    <p:sldId xmlns:r="http://schemas.openxmlformats.org/officeDocument/2006/relationships" id="260" r:id="R693f222fad354239"/>
+    <p:sldId xmlns:r="http://schemas.openxmlformats.org/officeDocument/2006/relationships" id="261" r:id="R2a75a6410fbb4dbc"/>
+    <p:sldId xmlns:r="http://schemas.openxmlformats.org/officeDocument/2006/relationships" id="262" r:id="Rb318bb224c2c474d"/>
+    <p:sldId xmlns:r="http://schemas.openxmlformats.org/officeDocument/2006/relationships" id="263" r:id="R7a3c07e6d1be4ea2"/>
+    <p:sldId xmlns:r="http://schemas.openxmlformats.org/officeDocument/2006/relationships" id="264" r:id="Rf8488a2e18c74fa2"/>
+    <p:sldId xmlns:r="http://schemas.openxmlformats.org/officeDocument/2006/relationships" id="265" r:id="R8fe261055d9c41a9"/>
+    <p:sldId xmlns:r="http://schemas.openxmlformats.org/officeDocument/2006/relationships" id="266" r:id="R476a6be3de7047d2"/>
+    <p:sldId xmlns:r="http://schemas.openxmlformats.org/officeDocument/2006/relationships" id="267" r:id="R2975e611ea6943e2"/>
+    <p:sldId xmlns:r="http://schemas.openxmlformats.org/officeDocument/2006/relationships" id="268" r:id="R77ca471175f64714"/>
   </p:sldIdLst>
   <p:sldSz cx="12192000" cy="6858000"/>
   <p:notesSz cx="6858000" cy="9144000"/>
@@ -634,7 +634,7 @@
           <a:lstStyle xmlns:a="http://schemas.openxmlformats.org/drawingml/2006/main"/>
           <a:p xmlns:a="http://schemas.openxmlformats.org/drawingml/2006/main">
             <a:r>
-              <a:t>Kai S. Kurono. Richtzeit: 1:10.</a:t>
+              <a:t>Jonaid Aydi. Richtzeit: 1:10.</a:t>
             </a:r>
           </a:p>
           <a:p xmlns:a="http://schemas.openxmlformats.org/drawingml/2006/main">
@@ -644,7 +644,7 @@
           </a:p>
           <a:p xmlns:a="http://schemas.openxmlformats.org/drawingml/2006/main">
             <a:r>
-              <a:t>Die Umsetzung bleibt bewusst überschaubar. prepare_data lädt und filtert den Korpus. run_analysis führt den vollständigen Reuters-Vergleich aus. Kleine Module trennen das Laden der Texte, die Merkmalsextraktion und die Distanzberechnung. CSV-Dateien enthalten die Merkmale und Vorhersagen. JSON-Dateien dokumentieren Parameter, Versionen und Hashes. Damit lassen sich Bericht und Berechnung zusammen prüfen. Der Kursbezug liegt unter anderem in Funktionen mit Docstrings, Dictionaries, virtuellen Umgebungen, NLTK, spaCy, pandas und NumPy. Die neue Installation reproduziert die früheren Vorhersagen vollständig. Fünf gezielte Funktionstests und alle drei Notebooks laufen durch. Die Federalist-Beispiele nutzen jetzt denselben bereinigten Textbestand. Ihre Kategorien unterscheiden eindeutige, umstrittene und gemeinsame Autorschaft. Sie dienen als historisches Zusatzbeispiel.</a:t>
+              <a:t>Die Umsetzung bleibt bewusst überschaubar. prepare_data lädt und filtert den Korpus. run_analysis führt den vollständigen Reuters-Vergleich aus. Kleine Module trennen das Laden der Texte, die Merkmalsextraktion und die Distanzberechnung. CSV-Dateien enthalten die Merkmale und Vorhersagen. JSON-Dateien dokumentieren Parameter, Versionen und Hashes. Damit lassen sich Bericht und Berechnung zusammen prüfen. Der Kursbezug liegt unter anderem in Funktionen mit Docstrings, Dictionaries, virtuellen Umgebungen, NLTK, spaCy, pandas und NumPy. Die neue Installation reproduziert die früheren Vorhersagen vollständig. Vier gezielte Funktionstests prüfen diese ergänzende Analyse. Kais drei Notebooks bleiben im ursprünglichen Stand. Jonaids Vergleich läuft unabhängig davon. Die Federalist-Beispiele gehören zu Kais historischer Exploration und gehen nicht in die ergänzende Reuters-Testauswertung ein.</a:t>
             </a:r>
           </a:p>
           <a:p xmlns:a="http://schemas.openxmlformats.org/drawingml/2006/main">
@@ -734,7 +734,7 @@
           </a:p>
           <a:p xmlns:a="http://schemas.openxmlformats.org/drawingml/2006/main">
             <a:r>
-              <a:t>Unsere Untersuchung zeigt, dass beide Repräsentationen für diese drei Reuters-Autoren nützliche Informationen enthalten. TF-IDF erzielt das beste Testergebnis. Autorenzentren verbessern den Stilansatz gegenüber einzelnen Nachbarn. Daraus folgt keine allgemeine Erkennung eines reinen persönlichen Stils. Themenunterschiede, verwandte Meldungen, redaktionelle Vorgaben und Texteigenschaften bleiben mögliche Einflüsse. Eine sinnvolle Fortsetzung wäre eine neue Autorenauswahl oder eine Auswertung mit kontrollierten Themen. Kai verantwortet die Wortrepräsentationen und die Exploration mit PCA, Clustering und Mystery-Zuordnung. Jonaid verantwortet den ergänzenden Stilvergleich, die Testauswertung und die Integration für reproduzierbare Läufe. Codex unterstützte die Integration, Prüfung und Vorbereitung der Unterlagen. Wir beide verantworten die Abgabe und ihre Erklärung. Damit öffnen wir die Diskussion.</a:t>
+              <a:t>Unsere Untersuchung zeigt, dass beide Repräsentationen für diese drei Reuters-Autoren nützliche Informationen enthalten. TF-IDF erzielt das beste Testergebnis. Autorenzentren verbessern den Stilansatz gegenüber einzelnen Nachbarn. Daraus folgt keine allgemeine Erkennung eines reinen persönlichen Stils. Themenunterschiede, verwandte Meldungen, redaktionelle Vorgaben und Texteigenschaften bleiben mögliche Einflüsse. Eine sinnvolle Fortsetzung wäre eine neue Autorenauswahl oder eine Auswertung mit kontrollierten Themen. Kai verantwortet die Wortrepräsentationen und die Exploration mit PCA, Clustering und Mystery-Zuordnung. Jonaid verantwortet den ergänzenden Stilvergleich, die Testauswertung und die Integration für reproduzierbare Läufe. Codex unterstützte Jonaids ergänzende Analyse, ihre Prüfung und die Vorbereitung der Unterlagen. Kais ursprüngliche Notebooks bleiben unverändert. Wir beide verantworten die Abgabe und ihre Erklärung. Damit öffnen wir die Diskussion.</a:t>
             </a:r>
           </a:p>
           <a:p xmlns:a="http://schemas.openxmlformats.org/drawingml/2006/main">
@@ -1622,7 +1622,7 @@
   </p:cSld>
   <p:clrMap bg1="lt1" tx1="dk1" bg2="lt2" tx2="dk2" accent1="accent1" accent2="accent2" accent3="accent3" accent4="accent4" accent5="accent5" accent6="accent6" hlink="hlink" folHlink="folHlink"/>
   <p:sldLayoutIdLst>
-    <p:sldLayoutId xmlns:r="http://schemas.openxmlformats.org/officeDocument/2006/relationships" id="2147483649" r:id="Rcca3523259ff479e"/>
+    <p:sldLayoutId xmlns:r="http://schemas.openxmlformats.org/officeDocument/2006/relationships" id="2147483649" r:id="Rf1300ea3f588422f"/>
   </p:sldLayoutIdLst>
   <p:txStyles>
     <p:titleStyle>
@@ -5059,7 +5059,7 @@
           <p:cNvPr id="6" name="">
             <a:extLst xmlns:a="http://schemas.openxmlformats.org/drawingml/2006/main">
               <a:ext uri="{FF2B5EF4-FFF2-40B4-BE49-F238E27FC236}">
-                <a16:creationId xmlns:a16="http://schemas.microsoft.com/office/drawing/2014/main" id="{694BFDFF-C9CF-4F8B-BE02-A7EBA19CB83B}"/>
+                <a16:creationId xmlns:a16="http://schemas.microsoft.com/office/drawing/2014/main" id="{69318844-B689-4F79-B61B-8864C5EE4816}"/>
               </a:ext>
             </a:extLst>
           </p:cNvPr>
@@ -5139,7 +5139,7 @@
           <p:cNvPr id="2" name="">
             <a:extLst xmlns:a="http://schemas.openxmlformats.org/drawingml/2006/main">
               <a:ext uri="{FF2B5EF4-FFF2-40B4-BE49-F238E27FC236}">
-                <a16:creationId xmlns:a16="http://schemas.microsoft.com/office/drawing/2014/main" id="{0484E325-F13A-4437-8291-A48CE00CE949}"/>
+                <a16:creationId xmlns:a16="http://schemas.microsoft.com/office/drawing/2014/main" id="{C5F6ACBC-BA35-4D52-A516-51AF7428D840}"/>
               </a:ext>
             </a:extLst>
           </p:cNvPr>
@@ -5196,7 +5196,7 @@
           <p:cNvPr id="3" name="">
             <a:extLst xmlns:a="http://schemas.openxmlformats.org/drawingml/2006/main">
               <a:ext uri="{FF2B5EF4-FFF2-40B4-BE49-F238E27FC236}">
-                <a16:creationId xmlns:a16="http://schemas.microsoft.com/office/drawing/2014/main" id="{F37D6ACA-DCEF-4CDC-B6FE-255EDBD6D3CC}"/>
+                <a16:creationId xmlns:a16="http://schemas.microsoft.com/office/drawing/2014/main" id="{6BE624F8-C9E1-496E-A230-34180B078436}"/>
               </a:ext>
             </a:extLst>
           </p:cNvPr>
@@ -5253,7 +5253,7 @@
           <p:cNvPr id="4" name="">
             <a:extLst xmlns:a="http://schemas.openxmlformats.org/drawingml/2006/main">
               <a:ext uri="{FF2B5EF4-FFF2-40B4-BE49-F238E27FC236}">
-                <a16:creationId xmlns:a16="http://schemas.microsoft.com/office/drawing/2014/main" id="{BBA35B3D-3A88-4F07-BD83-B5228AEF1F5C}"/>
+                <a16:creationId xmlns:a16="http://schemas.microsoft.com/office/drawing/2014/main" id="{E2E4DDAD-E052-4BF4-99CA-897A1422B192}"/>
               </a:ext>
             </a:extLst>
           </p:cNvPr>
@@ -5310,7 +5310,7 @@
           <p:cNvPr id="5" name="">
             <a:extLst xmlns:a="http://schemas.openxmlformats.org/drawingml/2006/main">
               <a:ext uri="{FF2B5EF4-FFF2-40B4-BE49-F238E27FC236}">
-                <a16:creationId xmlns:a16="http://schemas.microsoft.com/office/drawing/2014/main" id="{8D519802-0405-4EBE-8E23-2DBD66113B73}"/>
+                <a16:creationId xmlns:a16="http://schemas.microsoft.com/office/drawing/2014/main" id="{80B6547B-6DA6-4C51-9DBD-DD9647C1B56C}"/>
               </a:ext>
             </a:extLst>
           </p:cNvPr>
@@ -5365,7 +5365,7 @@
     </p:spTree>
     <p:extLst>
       <p:ext uri="{BB962C8B-B14F-4D97-AF65-F5344CB8AC3E}">
-        <p14:creationId xmlns:p14="http://schemas.microsoft.com/office/powerpoint/2010/main" val="1326537299"/>
+        <p14:creationId xmlns:p14="http://schemas.microsoft.com/office/powerpoint/2010/main" val="130953216"/>
       </p:ext>
     </p:extLst>
   </p:cSld>
@@ -5396,7 +5396,7 @@
           <p:cNvPr id="5" name="">
             <a:extLst xmlns:a="http://schemas.openxmlformats.org/drawingml/2006/main">
               <a:ext uri="{FF2B5EF4-FFF2-40B4-BE49-F238E27FC236}">
-                <a16:creationId xmlns:a16="http://schemas.microsoft.com/office/drawing/2014/main" id="{FE8074CB-6E48-4DE0-9A50-344B8024081F}"/>
+                <a16:creationId xmlns:a16="http://schemas.microsoft.com/office/drawing/2014/main" id="{519B60E0-FD73-4379-A031-FE848B2928B7}"/>
               </a:ext>
             </a:extLst>
           </p:cNvPr>
@@ -5453,7 +5453,7 @@
           <p:cNvPr id="2" name="">
             <a:extLst xmlns:a="http://schemas.openxmlformats.org/drawingml/2006/main">
               <a:ext uri="{FF2B5EF4-FFF2-40B4-BE49-F238E27FC236}">
-                <a16:creationId xmlns:a16="http://schemas.microsoft.com/office/drawing/2014/main" id="{E47FA66A-F7EF-4CE8-B0EA-13245229239D}"/>
+                <a16:creationId xmlns:a16="http://schemas.microsoft.com/office/drawing/2014/main" id="{11A51C68-E358-4CBD-934C-D64873FFEE9F}"/>
               </a:ext>
             </a:extLst>
           </p:cNvPr>
@@ -5926,7 +5926,7 @@
           <p:cNvPr id="4" name="">
             <a:extLst xmlns:a="http://schemas.openxmlformats.org/drawingml/2006/main">
               <a:ext uri="{FF2B5EF4-FFF2-40B4-BE49-F238E27FC236}">
-                <a16:creationId xmlns:a16="http://schemas.microsoft.com/office/drawing/2014/main" id="{A241FC2C-8443-471B-B68D-FCFA248CD4BF}"/>
+                <a16:creationId xmlns:a16="http://schemas.microsoft.com/office/drawing/2014/main" id="{0D1F8752-4FB9-4013-8E30-231A8ADA8570}"/>
               </a:ext>
             </a:extLst>
           </p:cNvPr>
@@ -5981,7 +5981,7 @@
     </p:spTree>
     <p:extLst>
       <p:ext uri="{BB962C8B-B14F-4D97-AF65-F5344CB8AC3E}">
-        <p14:creationId xmlns:p14="http://schemas.microsoft.com/office/powerpoint/2010/main" val="2054107322"/>
+        <p14:creationId xmlns:p14="http://schemas.microsoft.com/office/powerpoint/2010/main" val="1288513039"/>
       </p:ext>
     </p:extLst>
   </p:cSld>
@@ -6012,7 +6012,7 @@
           <p:cNvPr id="7" name="">
             <a:extLst xmlns:a="http://schemas.openxmlformats.org/drawingml/2006/main">
               <a:ext uri="{FF2B5EF4-FFF2-40B4-BE49-F238E27FC236}">
-                <a16:creationId xmlns:a16="http://schemas.microsoft.com/office/drawing/2014/main" id="{D8FC5DCB-373D-4655-B0B1-5BC215339E94}"/>
+                <a16:creationId xmlns:a16="http://schemas.microsoft.com/office/drawing/2014/main" id="{9F638AD7-E7CB-47D4-B51D-10B5EB3D62CF}"/>
               </a:ext>
             </a:extLst>
           </p:cNvPr>
@@ -6069,7 +6069,7 @@
           <p:cNvPr id="2" name="">
             <a:extLst xmlns:a="http://schemas.openxmlformats.org/drawingml/2006/main">
               <a:ext uri="{FF2B5EF4-FFF2-40B4-BE49-F238E27FC236}">
-                <a16:creationId xmlns:a16="http://schemas.microsoft.com/office/drawing/2014/main" id="{E00B8191-AFCC-43FB-BE1E-CB87CB68580E}"/>
+                <a16:creationId xmlns:a16="http://schemas.microsoft.com/office/drawing/2014/main" id="{2CC8C1AD-BF9D-473A-A6E8-868AEBE46D1A}"/>
               </a:ext>
             </a:extLst>
           </p:cNvPr>
@@ -6126,7 +6126,7 @@
           <p:cNvPr id="3" name="">
             <a:extLst xmlns:a="http://schemas.openxmlformats.org/drawingml/2006/main">
               <a:ext uri="{FF2B5EF4-FFF2-40B4-BE49-F238E27FC236}">
-                <a16:creationId xmlns:a16="http://schemas.microsoft.com/office/drawing/2014/main" id="{F82EF043-E360-41F9-8A13-11315BE1437B}"/>
+                <a16:creationId xmlns:a16="http://schemas.microsoft.com/office/drawing/2014/main" id="{5BBFE80B-FC65-4309-87D3-929D48D56FBD}"/>
               </a:ext>
             </a:extLst>
           </p:cNvPr>
@@ -6183,7 +6183,7 @@
           <p:cNvPr id="4" name="">
             <a:extLst xmlns:a="http://schemas.openxmlformats.org/drawingml/2006/main">
               <a:ext uri="{FF2B5EF4-FFF2-40B4-BE49-F238E27FC236}">
-                <a16:creationId xmlns:a16="http://schemas.microsoft.com/office/drawing/2014/main" id="{F498FA3D-3C60-47D7-91E0-EB18E18233C6}"/>
+                <a16:creationId xmlns:a16="http://schemas.microsoft.com/office/drawing/2014/main" id="{2B9E88EA-AE64-4C7D-8263-54807BB92C4C}"/>
               </a:ext>
             </a:extLst>
           </p:cNvPr>
@@ -6240,7 +6240,7 @@
           <p:cNvPr id="5" name="">
             <a:extLst xmlns:a="http://schemas.openxmlformats.org/drawingml/2006/main">
               <a:ext uri="{FF2B5EF4-FFF2-40B4-BE49-F238E27FC236}">
-                <a16:creationId xmlns:a16="http://schemas.microsoft.com/office/drawing/2014/main" id="{53AA9681-7702-4345-BB50-E1A6800AB14E}"/>
+                <a16:creationId xmlns:a16="http://schemas.microsoft.com/office/drawing/2014/main" id="{B6E66934-0FF6-471F-868E-786538F4A1C8}"/>
               </a:ext>
             </a:extLst>
           </p:cNvPr>
@@ -6297,7 +6297,7 @@
           <p:cNvPr id="6" name="">
             <a:extLst xmlns:a="http://schemas.openxmlformats.org/drawingml/2006/main">
               <a:ext uri="{FF2B5EF4-FFF2-40B4-BE49-F238E27FC236}">
-                <a16:creationId xmlns:a16="http://schemas.microsoft.com/office/drawing/2014/main" id="{64DB399B-8426-4DDD-93C2-36BAB252EBA7}"/>
+                <a16:creationId xmlns:a16="http://schemas.microsoft.com/office/drawing/2014/main" id="{44EE8413-AC66-464B-8CD3-4BB8A3C36626}"/>
               </a:ext>
             </a:extLst>
           </p:cNvPr>
@@ -6344,7 +6344,7 @@
                 <a:ea typeface="Arial"/>
                 <a:cs typeface="Arial"/>
               </a:rPr>
-              <a:t>Neue Umgebung, fünf Funktionstests und drei geprüfte Notebooks</a:t>
+              <a:t>Neue Umgebung und vier Tests für Jonaids Vergleich</a:t>
             </a:r>
           </a:p>
         </p:txBody>
@@ -6352,7 +6352,7 @@
     </p:spTree>
     <p:extLst>
       <p:ext uri="{BB962C8B-B14F-4D97-AF65-F5344CB8AC3E}">
-        <p14:creationId xmlns:p14="http://schemas.microsoft.com/office/powerpoint/2010/main" val="1049169016"/>
+        <p14:creationId xmlns:p14="http://schemas.microsoft.com/office/powerpoint/2010/main" val="1595166885"/>
       </p:ext>
     </p:extLst>
   </p:cSld>
@@ -6383,7 +6383,7 @@
           <p:cNvPr id="8" name="">
             <a:extLst xmlns:a="http://schemas.openxmlformats.org/drawingml/2006/main">
               <a:ext uri="{FF2B5EF4-FFF2-40B4-BE49-F238E27FC236}">
-                <a16:creationId xmlns:a16="http://schemas.microsoft.com/office/drawing/2014/main" id="{07799CA4-91D0-430F-8893-E7E8B5BCEBA6}"/>
+                <a16:creationId xmlns:a16="http://schemas.microsoft.com/office/drawing/2014/main" id="{D52F32D3-0291-4998-AB65-10DB5F3B81BB}"/>
               </a:ext>
             </a:extLst>
           </p:cNvPr>
@@ -6440,7 +6440,7 @@
           <p:cNvPr id="2" name="">
             <a:extLst xmlns:a="http://schemas.openxmlformats.org/drawingml/2006/main">
               <a:ext uri="{FF2B5EF4-FFF2-40B4-BE49-F238E27FC236}">
-                <a16:creationId xmlns:a16="http://schemas.microsoft.com/office/drawing/2014/main" id="{A88E6A9A-B08C-4E84-8267-602E045469CA}"/>
+                <a16:creationId xmlns:a16="http://schemas.microsoft.com/office/drawing/2014/main" id="{DAB9C666-4868-44F5-9DF0-0A0D85D57901}"/>
               </a:ext>
             </a:extLst>
           </p:cNvPr>
@@ -6497,7 +6497,7 @@
           <p:cNvPr id="3" name="">
             <a:extLst xmlns:a="http://schemas.openxmlformats.org/drawingml/2006/main">
               <a:ext uri="{FF2B5EF4-FFF2-40B4-BE49-F238E27FC236}">
-                <a16:creationId xmlns:a16="http://schemas.microsoft.com/office/drawing/2014/main" id="{24A2635B-EAD1-4791-83FA-D094B6207DE7}"/>
+                <a16:creationId xmlns:a16="http://schemas.microsoft.com/office/drawing/2014/main" id="{CAAFB496-A964-4750-A462-3D3D5F575127}"/>
               </a:ext>
             </a:extLst>
           </p:cNvPr>
@@ -6554,7 +6554,7 @@
           <p:cNvPr id="4" name="">
             <a:extLst xmlns:a="http://schemas.openxmlformats.org/drawingml/2006/main">
               <a:ext uri="{FF2B5EF4-FFF2-40B4-BE49-F238E27FC236}">
-                <a16:creationId xmlns:a16="http://schemas.microsoft.com/office/drawing/2014/main" id="{C9F0159C-BB0B-4003-B29A-C12DE6DDA1F2}"/>
+                <a16:creationId xmlns:a16="http://schemas.microsoft.com/office/drawing/2014/main" id="{AA2A24BA-92A4-4BA6-84B1-07DD1499F9DE}"/>
               </a:ext>
             </a:extLst>
           </p:cNvPr>
@@ -6611,7 +6611,7 @@
           <p:cNvPr id="5" name="">
             <a:extLst xmlns:a="http://schemas.openxmlformats.org/drawingml/2006/main">
               <a:ext uri="{FF2B5EF4-FFF2-40B4-BE49-F238E27FC236}">
-                <a16:creationId xmlns:a16="http://schemas.microsoft.com/office/drawing/2014/main" id="{126B5874-0EB9-47DE-AA12-DB2C71F5581C}"/>
+                <a16:creationId xmlns:a16="http://schemas.microsoft.com/office/drawing/2014/main" id="{50D8B06C-E462-475B-A498-DBFC02F35E1C}"/>
               </a:ext>
             </a:extLst>
           </p:cNvPr>
@@ -6668,7 +6668,7 @@
           <p:cNvPr id="6" name="">
             <a:extLst xmlns:a="http://schemas.openxmlformats.org/drawingml/2006/main">
               <a:ext uri="{FF2B5EF4-FFF2-40B4-BE49-F238E27FC236}">
-                <a16:creationId xmlns:a16="http://schemas.microsoft.com/office/drawing/2014/main" id="{134C638D-4B54-40FF-8346-B24F62FE6E74}"/>
+                <a16:creationId xmlns:a16="http://schemas.microsoft.com/office/drawing/2014/main" id="{5C1AD1EB-3E29-4C03-AA0A-7301383C07CC}"/>
               </a:ext>
             </a:extLst>
           </p:cNvPr>
@@ -6725,7 +6725,7 @@
           <p:cNvPr id="7" name="">
             <a:extLst xmlns:a="http://schemas.openxmlformats.org/drawingml/2006/main">
               <a:ext uri="{FF2B5EF4-FFF2-40B4-BE49-F238E27FC236}">
-                <a16:creationId xmlns:a16="http://schemas.microsoft.com/office/drawing/2014/main" id="{56B229DF-D8AB-41BF-A323-08D84F4975D7}"/>
+                <a16:creationId xmlns:a16="http://schemas.microsoft.com/office/drawing/2014/main" id="{4DF092C6-5071-4B3F-8129-BF4A50DC93EE}"/>
               </a:ext>
             </a:extLst>
           </p:cNvPr>
@@ -6780,7 +6780,7 @@
     </p:spTree>
     <p:extLst>
       <p:ext uri="{BB962C8B-B14F-4D97-AF65-F5344CB8AC3E}">
-        <p14:creationId xmlns:p14="http://schemas.microsoft.com/office/powerpoint/2010/main" val="931724006"/>
+        <p14:creationId xmlns:p14="http://schemas.microsoft.com/office/powerpoint/2010/main" val="1280279230"/>
       </p:ext>
     </p:extLst>
   </p:cSld>
@@ -6811,7 +6811,7 @@
           <p:cNvPr id="7" name="">
             <a:extLst xmlns:a="http://schemas.openxmlformats.org/drawingml/2006/main">
               <a:ext uri="{FF2B5EF4-FFF2-40B4-BE49-F238E27FC236}">
-                <a16:creationId xmlns:a16="http://schemas.microsoft.com/office/drawing/2014/main" id="{04077836-ED14-4673-A65C-50BEF0BA73BA}"/>
+                <a16:creationId xmlns:a16="http://schemas.microsoft.com/office/drawing/2014/main" id="{609C52AF-E185-4A49-BBA6-1829576D04AC}"/>
               </a:ext>
             </a:extLst>
           </p:cNvPr>
@@ -6868,7 +6868,7 @@
           <p:cNvPr id="2" name="">
             <a:extLst xmlns:a="http://schemas.openxmlformats.org/drawingml/2006/main">
               <a:ext uri="{FF2B5EF4-FFF2-40B4-BE49-F238E27FC236}">
-                <a16:creationId xmlns:a16="http://schemas.microsoft.com/office/drawing/2014/main" id="{EC82CE67-1028-4352-9B15-D3317CE75DB6}"/>
+                <a16:creationId xmlns:a16="http://schemas.microsoft.com/office/drawing/2014/main" id="{B981B701-EF62-461C-8E23-2162FB1ECF32}"/>
               </a:ext>
             </a:extLst>
           </p:cNvPr>
@@ -6925,7 +6925,7 @@
           <p:cNvPr id="3" name="">
             <a:extLst xmlns:a="http://schemas.openxmlformats.org/drawingml/2006/main">
               <a:ext uri="{FF2B5EF4-FFF2-40B4-BE49-F238E27FC236}">
-                <a16:creationId xmlns:a16="http://schemas.microsoft.com/office/drawing/2014/main" id="{79C888FB-2F92-4CBC-9B9A-2937F043E7ED}"/>
+                <a16:creationId xmlns:a16="http://schemas.microsoft.com/office/drawing/2014/main" id="{DE51CCE8-7BF3-4475-94A3-D8AFC088EFCD}"/>
               </a:ext>
             </a:extLst>
           </p:cNvPr>
@@ -6982,7 +6982,7 @@
           <p:cNvPr id="4" name="">
             <a:extLst xmlns:a="http://schemas.openxmlformats.org/drawingml/2006/main">
               <a:ext uri="{FF2B5EF4-FFF2-40B4-BE49-F238E27FC236}">
-                <a16:creationId xmlns:a16="http://schemas.microsoft.com/office/drawing/2014/main" id="{1C07A3C9-7CF7-42FA-A167-CE755AB51B2C}"/>
+                <a16:creationId xmlns:a16="http://schemas.microsoft.com/office/drawing/2014/main" id="{0533E9CE-57CB-4448-B3B1-62CF688C01DF}"/>
               </a:ext>
             </a:extLst>
           </p:cNvPr>
@@ -7039,7 +7039,7 @@
           <p:cNvPr id="5" name="">
             <a:extLst xmlns:a="http://schemas.openxmlformats.org/drawingml/2006/main">
               <a:ext uri="{FF2B5EF4-FFF2-40B4-BE49-F238E27FC236}">
-                <a16:creationId xmlns:a16="http://schemas.microsoft.com/office/drawing/2014/main" id="{142347F2-9BDE-4669-AC68-F841444A1117}"/>
+                <a16:creationId xmlns:a16="http://schemas.microsoft.com/office/drawing/2014/main" id="{6B248FD1-5D4A-495A-BDFE-95B2C274D17C}"/>
               </a:ext>
             </a:extLst>
           </p:cNvPr>
@@ -7096,7 +7096,7 @@
           <p:cNvPr id="6" name="">
             <a:extLst xmlns:a="http://schemas.openxmlformats.org/drawingml/2006/main">
               <a:ext uri="{FF2B5EF4-FFF2-40B4-BE49-F238E27FC236}">
-                <a16:creationId xmlns:a16="http://schemas.microsoft.com/office/drawing/2014/main" id="{7C3197B3-9D4D-4B6C-BCB1-6C0F5D183E3D}"/>
+                <a16:creationId xmlns:a16="http://schemas.microsoft.com/office/drawing/2014/main" id="{C40A1AE7-1BAB-473C-85AD-4C0627997FD9}"/>
               </a:ext>
             </a:extLst>
           </p:cNvPr>
@@ -7151,7 +7151,7 @@
     </p:spTree>
     <p:extLst>
       <p:ext uri="{BB962C8B-B14F-4D97-AF65-F5344CB8AC3E}">
-        <p14:creationId xmlns:p14="http://schemas.microsoft.com/office/powerpoint/2010/main" val="1330035083"/>
+        <p14:creationId xmlns:p14="http://schemas.microsoft.com/office/powerpoint/2010/main" val="949868375"/>
       </p:ext>
     </p:extLst>
   </p:cSld>
@@ -7182,7 +7182,7 @@
           <p:cNvPr id="6" name="">
             <a:extLst xmlns:a="http://schemas.openxmlformats.org/drawingml/2006/main">
               <a:ext uri="{FF2B5EF4-FFF2-40B4-BE49-F238E27FC236}">
-                <a16:creationId xmlns:a16="http://schemas.microsoft.com/office/drawing/2014/main" id="{098C10A0-2900-415A-9604-A2492FD0FA2E}"/>
+                <a16:creationId xmlns:a16="http://schemas.microsoft.com/office/drawing/2014/main" id="{036AB3A3-934A-4E9C-A176-241F3259E330}"/>
               </a:ext>
             </a:extLst>
           </p:cNvPr>
@@ -7239,7 +7239,7 @@
           <p:cNvPr id="2" name="">
             <a:extLst xmlns:a="http://schemas.openxmlformats.org/drawingml/2006/main">
               <a:ext uri="{FF2B5EF4-FFF2-40B4-BE49-F238E27FC236}">
-                <a16:creationId xmlns:a16="http://schemas.microsoft.com/office/drawing/2014/main" id="{BCE1E5B0-15D3-47D9-AA87-04C74D7E1B91}"/>
+                <a16:creationId xmlns:a16="http://schemas.microsoft.com/office/drawing/2014/main" id="{2D53ABFB-C352-4527-ABF5-807F136364B8}"/>
               </a:ext>
             </a:extLst>
           </p:cNvPr>
@@ -7296,7 +7296,7 @@
           <p:cNvPr id="3" name="">
             <a:extLst xmlns:a="http://schemas.openxmlformats.org/drawingml/2006/main">
               <a:ext uri="{FF2B5EF4-FFF2-40B4-BE49-F238E27FC236}">
-                <a16:creationId xmlns:a16="http://schemas.microsoft.com/office/drawing/2014/main" id="{A8160B22-0C3B-4EDB-9223-C65F38B0DEFE}"/>
+                <a16:creationId xmlns:a16="http://schemas.microsoft.com/office/drawing/2014/main" id="{26B2C552-CE10-41B6-9336-A9EC71C7C8F8}"/>
               </a:ext>
             </a:extLst>
           </p:cNvPr>
@@ -7376,7 +7376,7 @@
           <p:cNvPr id="4" name="">
             <a:extLst xmlns:a="http://schemas.openxmlformats.org/drawingml/2006/main">
               <a:ext uri="{FF2B5EF4-FFF2-40B4-BE49-F238E27FC236}">
-                <a16:creationId xmlns:a16="http://schemas.microsoft.com/office/drawing/2014/main" id="{6B58A961-C11D-4C63-932F-BADAD1CD6C49}"/>
+                <a16:creationId xmlns:a16="http://schemas.microsoft.com/office/drawing/2014/main" id="{451E70B6-0132-4579-8B0B-9B270C19F269}"/>
               </a:ext>
             </a:extLst>
           </p:cNvPr>
@@ -7433,7 +7433,7 @@
           <p:cNvPr id="5" name="">
             <a:extLst xmlns:a="http://schemas.openxmlformats.org/drawingml/2006/main">
               <a:ext uri="{FF2B5EF4-FFF2-40B4-BE49-F238E27FC236}">
-                <a16:creationId xmlns:a16="http://schemas.microsoft.com/office/drawing/2014/main" id="{95EAE710-FF88-43DE-A1C6-19113ADCB2FB}"/>
+                <a16:creationId xmlns:a16="http://schemas.microsoft.com/office/drawing/2014/main" id="{49EDC168-76C2-4A59-9A66-0305C849D083}"/>
               </a:ext>
             </a:extLst>
           </p:cNvPr>
@@ -7488,7 +7488,7 @@
     </p:spTree>
     <p:extLst>
       <p:ext uri="{BB962C8B-B14F-4D97-AF65-F5344CB8AC3E}">
-        <p14:creationId xmlns:p14="http://schemas.microsoft.com/office/powerpoint/2010/main" val="1778342729"/>
+        <p14:creationId xmlns:p14="http://schemas.microsoft.com/office/powerpoint/2010/main" val="1386294556"/>
       </p:ext>
     </p:extLst>
   </p:cSld>
@@ -7519,7 +7519,7 @@
           <p:cNvPr id="5" name="">
             <a:extLst xmlns:a="http://schemas.openxmlformats.org/drawingml/2006/main">
               <a:ext uri="{FF2B5EF4-FFF2-40B4-BE49-F238E27FC236}">
-                <a16:creationId xmlns:a16="http://schemas.microsoft.com/office/drawing/2014/main" id="{4A0A655F-9D50-46A4-B0CD-5A39A89A040A}"/>
+                <a16:creationId xmlns:a16="http://schemas.microsoft.com/office/drawing/2014/main" id="{9B3C7316-A870-4614-8C92-B56A29987565}"/>
               </a:ext>
             </a:extLst>
           </p:cNvPr>
@@ -7576,7 +7576,7 @@
           <p:cNvPr id="2" name="">
             <a:extLst xmlns:a="http://schemas.openxmlformats.org/drawingml/2006/main">
               <a:ext uri="{FF2B5EF4-FFF2-40B4-BE49-F238E27FC236}">
-                <a16:creationId xmlns:a16="http://schemas.microsoft.com/office/drawing/2014/main" id="{E27952D8-9961-4876-BFBE-ED771E23B9E1}"/>
+                <a16:creationId xmlns:a16="http://schemas.microsoft.com/office/drawing/2014/main" id="{87C4E46C-373B-45DF-B3FC-8E1AD1F86F21}"/>
               </a:ext>
             </a:extLst>
           </p:cNvPr>
@@ -8147,7 +8147,7 @@
           <p:cNvPr id="4" name="">
             <a:extLst xmlns:a="http://schemas.openxmlformats.org/drawingml/2006/main">
               <a:ext uri="{FF2B5EF4-FFF2-40B4-BE49-F238E27FC236}">
-                <a16:creationId xmlns:a16="http://schemas.microsoft.com/office/drawing/2014/main" id="{A386B6CC-0F40-4210-868F-B1529AEB4CBB}"/>
+                <a16:creationId xmlns:a16="http://schemas.microsoft.com/office/drawing/2014/main" id="{A2727A7F-9C0E-4315-BC97-EE25D70A5DD5}"/>
               </a:ext>
             </a:extLst>
           </p:cNvPr>
@@ -8202,7 +8202,7 @@
     </p:spTree>
     <p:extLst>
       <p:ext uri="{BB962C8B-B14F-4D97-AF65-F5344CB8AC3E}">
-        <p14:creationId xmlns:p14="http://schemas.microsoft.com/office/powerpoint/2010/main" val="1961741475"/>
+        <p14:creationId xmlns:p14="http://schemas.microsoft.com/office/powerpoint/2010/main" val="1491291930"/>
       </p:ext>
     </p:extLst>
   </p:cSld>
@@ -8233,7 +8233,7 @@
           <p:cNvPr id="7" name="">
             <a:extLst xmlns:a="http://schemas.openxmlformats.org/drawingml/2006/main">
               <a:ext uri="{FF2B5EF4-FFF2-40B4-BE49-F238E27FC236}">
-                <a16:creationId xmlns:a16="http://schemas.microsoft.com/office/drawing/2014/main" id="{1EF44415-821C-4621-8509-09BD9051B050}"/>
+                <a16:creationId xmlns:a16="http://schemas.microsoft.com/office/drawing/2014/main" id="{8A9D1CFD-D9FD-4330-91F6-31A47D017EC1}"/>
               </a:ext>
             </a:extLst>
           </p:cNvPr>
@@ -8290,7 +8290,7 @@
           <p:cNvPr id="2" name="">
             <a:extLst xmlns:a="http://schemas.openxmlformats.org/drawingml/2006/main">
               <a:ext uri="{FF2B5EF4-FFF2-40B4-BE49-F238E27FC236}">
-                <a16:creationId xmlns:a16="http://schemas.microsoft.com/office/drawing/2014/main" id="{CBE99FA3-62EA-4EDE-9719-3FB343699484}"/>
+                <a16:creationId xmlns:a16="http://schemas.microsoft.com/office/drawing/2014/main" id="{0C618788-EF6C-4FB4-B3E0-16FEB299D13B}"/>
               </a:ext>
             </a:extLst>
           </p:cNvPr>
@@ -8347,7 +8347,7 @@
           <p:cNvPr id="3" name="">
             <a:extLst xmlns:a="http://schemas.openxmlformats.org/drawingml/2006/main">
               <a:ext uri="{FF2B5EF4-FFF2-40B4-BE49-F238E27FC236}">
-                <a16:creationId xmlns:a16="http://schemas.microsoft.com/office/drawing/2014/main" id="{1C1704CE-AF70-4EDD-B5C6-332138460455}"/>
+                <a16:creationId xmlns:a16="http://schemas.microsoft.com/office/drawing/2014/main" id="{7080CCE0-CB64-4C6E-B3E0-5CC977535605}"/>
               </a:ext>
             </a:extLst>
           </p:cNvPr>
@@ -8404,7 +8404,7 @@
           <p:cNvPr id="4" name="">
             <a:extLst xmlns:a="http://schemas.openxmlformats.org/drawingml/2006/main">
               <a:ext uri="{FF2B5EF4-FFF2-40B4-BE49-F238E27FC236}">
-                <a16:creationId xmlns:a16="http://schemas.microsoft.com/office/drawing/2014/main" id="{7F378952-B10A-4B11-B293-DD4124020B74}"/>
+                <a16:creationId xmlns:a16="http://schemas.microsoft.com/office/drawing/2014/main" id="{722C413A-DFCB-409A-AD1F-2023C1BA30BC}"/>
               </a:ext>
             </a:extLst>
           </p:cNvPr>
@@ -8461,7 +8461,7 @@
           <p:cNvPr id="5" name="">
             <a:extLst xmlns:a="http://schemas.openxmlformats.org/drawingml/2006/main">
               <a:ext uri="{FF2B5EF4-FFF2-40B4-BE49-F238E27FC236}">
-                <a16:creationId xmlns:a16="http://schemas.microsoft.com/office/drawing/2014/main" id="{A1C6AECE-D557-46B2-AB8E-6ED2FCA09377}"/>
+                <a16:creationId xmlns:a16="http://schemas.microsoft.com/office/drawing/2014/main" id="{E89F287B-1C50-4BCA-BCCE-AFE99DCBF2B0}"/>
               </a:ext>
             </a:extLst>
           </p:cNvPr>
@@ -8518,7 +8518,7 @@
           <p:cNvPr id="6" name="">
             <a:extLst xmlns:a="http://schemas.openxmlformats.org/drawingml/2006/main">
               <a:ext uri="{FF2B5EF4-FFF2-40B4-BE49-F238E27FC236}">
-                <a16:creationId xmlns:a16="http://schemas.microsoft.com/office/drawing/2014/main" id="{9CE6AE20-CA9F-4C8E-8C0C-6B00F8E16F0A}"/>
+                <a16:creationId xmlns:a16="http://schemas.microsoft.com/office/drawing/2014/main" id="{98DF7CC9-E58E-4A96-843B-1D7B65637041}"/>
               </a:ext>
             </a:extLst>
           </p:cNvPr>
@@ -8573,7 +8573,7 @@
     </p:spTree>
     <p:extLst>
       <p:ext uri="{BB962C8B-B14F-4D97-AF65-F5344CB8AC3E}">
-        <p14:creationId xmlns:p14="http://schemas.microsoft.com/office/powerpoint/2010/main" val="2107008960"/>
+        <p14:creationId xmlns:p14="http://schemas.microsoft.com/office/powerpoint/2010/main" val="1981027575"/>
       </p:ext>
     </p:extLst>
   </p:cSld>
@@ -8604,7 +8604,7 @@
           <p:cNvPr id="6" name="">
             <a:extLst xmlns:a="http://schemas.openxmlformats.org/drawingml/2006/main">
               <a:ext uri="{FF2B5EF4-FFF2-40B4-BE49-F238E27FC236}">
-                <a16:creationId xmlns:a16="http://schemas.microsoft.com/office/drawing/2014/main" id="{A219DF7A-9B24-44AC-9BA1-CD544DB1A2CA}"/>
+                <a16:creationId xmlns:a16="http://schemas.microsoft.com/office/drawing/2014/main" id="{6E917AD1-B667-441C-A352-FE49392ADD5B}"/>
               </a:ext>
             </a:extLst>
           </p:cNvPr>
@@ -8661,7 +8661,7 @@
           <p:cNvPr id="2" name="">
             <a:extLst xmlns:a="http://schemas.openxmlformats.org/drawingml/2006/main">
               <a:ext uri="{FF2B5EF4-FFF2-40B4-BE49-F238E27FC236}">
-                <a16:creationId xmlns:a16="http://schemas.microsoft.com/office/drawing/2014/main" id="{452809A0-459D-4B72-A885-2A6468FC5AB3}"/>
+                <a16:creationId xmlns:a16="http://schemas.microsoft.com/office/drawing/2014/main" id="{C9F476E6-5C1A-496A-BD37-5AF2F33B1505}"/>
               </a:ext>
             </a:extLst>
           </p:cNvPr>
@@ -9037,7 +9037,7 @@
           <p:cNvPr id="4" name="">
             <a:extLst xmlns:a="http://schemas.openxmlformats.org/drawingml/2006/main">
               <a:ext uri="{FF2B5EF4-FFF2-40B4-BE49-F238E27FC236}">
-                <a16:creationId xmlns:a16="http://schemas.microsoft.com/office/drawing/2014/main" id="{E2B23C71-D436-4C11-8D35-9FAA3F5FF994}"/>
+                <a16:creationId xmlns:a16="http://schemas.microsoft.com/office/drawing/2014/main" id="{81CC073E-9DC8-4990-81F8-58ED4A59FE9A}"/>
               </a:ext>
             </a:extLst>
           </p:cNvPr>
@@ -9094,7 +9094,7 @@
           <p:cNvPr id="5" name="">
             <a:extLst xmlns:a="http://schemas.openxmlformats.org/drawingml/2006/main">
               <a:ext uri="{FF2B5EF4-FFF2-40B4-BE49-F238E27FC236}">
-                <a16:creationId xmlns:a16="http://schemas.microsoft.com/office/drawing/2014/main" id="{FBD4BA3E-E4A5-40F5-81C3-E7C78F228B39}"/>
+                <a16:creationId xmlns:a16="http://schemas.microsoft.com/office/drawing/2014/main" id="{897B932C-2895-415C-9933-B62BCAD4EB4D}"/>
               </a:ext>
             </a:extLst>
           </p:cNvPr>
@@ -9149,7 +9149,7 @@
     </p:spTree>
     <p:extLst>
       <p:ext uri="{BB962C8B-B14F-4D97-AF65-F5344CB8AC3E}">
-        <p14:creationId xmlns:p14="http://schemas.microsoft.com/office/powerpoint/2010/main" val="1463726779"/>
+        <p14:creationId xmlns:p14="http://schemas.microsoft.com/office/powerpoint/2010/main" val="661013522"/>
       </p:ext>
     </p:extLst>
   </p:cSld>
@@ -9180,7 +9180,7 @@
           <p:cNvPr id="8" name="">
             <a:extLst xmlns:a="http://schemas.openxmlformats.org/drawingml/2006/main">
               <a:ext uri="{FF2B5EF4-FFF2-40B4-BE49-F238E27FC236}">
-                <a16:creationId xmlns:a16="http://schemas.microsoft.com/office/drawing/2014/main" id="{16D78C9E-EFF4-4F35-A913-D21DB6DC1A64}"/>
+                <a16:creationId xmlns:a16="http://schemas.microsoft.com/office/drawing/2014/main" id="{503F9232-446A-46D1-AC5C-FF9D3E34279E}"/>
               </a:ext>
             </a:extLst>
           </p:cNvPr>
@@ -9237,7 +9237,7 @@
           <p:cNvPr id="2" name="">
             <a:extLst xmlns:a="http://schemas.openxmlformats.org/drawingml/2006/main">
               <a:ext uri="{FF2B5EF4-FFF2-40B4-BE49-F238E27FC236}">
-                <a16:creationId xmlns:a16="http://schemas.microsoft.com/office/drawing/2014/main" id="{F5C1C289-AE34-46D8-925F-D23A2847C3E0}"/>
+                <a16:creationId xmlns:a16="http://schemas.microsoft.com/office/drawing/2014/main" id="{BC5688E0-53CF-4F76-BCCF-A086EAA3A28E}"/>
               </a:ext>
             </a:extLst>
           </p:cNvPr>
@@ -9294,7 +9294,7 @@
           <p:cNvPr id="3" name="">
             <a:extLst xmlns:a="http://schemas.openxmlformats.org/drawingml/2006/main">
               <a:ext uri="{FF2B5EF4-FFF2-40B4-BE49-F238E27FC236}">
-                <a16:creationId xmlns:a16="http://schemas.microsoft.com/office/drawing/2014/main" id="{5315D0D4-469E-4AE5-B6B6-155F125109EB}"/>
+                <a16:creationId xmlns:a16="http://schemas.microsoft.com/office/drawing/2014/main" id="{BB65E621-476C-4D6C-B2ED-3BDD6947FA91}"/>
               </a:ext>
             </a:extLst>
           </p:cNvPr>
@@ -9351,7 +9351,7 @@
           <p:cNvPr id="4" name="">
             <a:extLst xmlns:a="http://schemas.openxmlformats.org/drawingml/2006/main">
               <a:ext uri="{FF2B5EF4-FFF2-40B4-BE49-F238E27FC236}">
-                <a16:creationId xmlns:a16="http://schemas.microsoft.com/office/drawing/2014/main" id="{EB348516-D268-4819-837F-86CD5F6AD6A2}"/>
+                <a16:creationId xmlns:a16="http://schemas.microsoft.com/office/drawing/2014/main" id="{2A9C9A29-D9B8-4C3F-A43A-E811527E5B0E}"/>
               </a:ext>
             </a:extLst>
           </p:cNvPr>
@@ -9431,7 +9431,7 @@
           <p:cNvPr id="5" name="">
             <a:extLst xmlns:a="http://schemas.openxmlformats.org/drawingml/2006/main">
               <a:ext uri="{FF2B5EF4-FFF2-40B4-BE49-F238E27FC236}">
-                <a16:creationId xmlns:a16="http://schemas.microsoft.com/office/drawing/2014/main" id="{93EB35AC-655F-4665-B01B-0563CF59BC62}"/>
+                <a16:creationId xmlns:a16="http://schemas.microsoft.com/office/drawing/2014/main" id="{AF13AD2C-2234-4D99-AAC1-0D787D4A38C9}"/>
               </a:ext>
             </a:extLst>
           </p:cNvPr>
@@ -9488,7 +9488,7 @@
           <p:cNvPr id="6" name="">
             <a:extLst xmlns:a="http://schemas.openxmlformats.org/drawingml/2006/main">
               <a:ext uri="{FF2B5EF4-FFF2-40B4-BE49-F238E27FC236}">
-                <a16:creationId xmlns:a16="http://schemas.microsoft.com/office/drawing/2014/main" id="{C15B70F5-F7D4-4EA0-96FD-02CD15C6BC3A}"/>
+                <a16:creationId xmlns:a16="http://schemas.microsoft.com/office/drawing/2014/main" id="{3EE95AE9-9D62-4BBA-9300-A44643DAF8AC}"/>
               </a:ext>
             </a:extLst>
           </p:cNvPr>
@@ -9568,7 +9568,7 @@
           <p:cNvPr id="7" name="">
             <a:extLst xmlns:a="http://schemas.openxmlformats.org/drawingml/2006/main">
               <a:ext uri="{FF2B5EF4-FFF2-40B4-BE49-F238E27FC236}">
-                <a16:creationId xmlns:a16="http://schemas.microsoft.com/office/drawing/2014/main" id="{EED699F9-35C3-497F-A25D-A9F02F746337}"/>
+                <a16:creationId xmlns:a16="http://schemas.microsoft.com/office/drawing/2014/main" id="{648A9571-D255-4C7A-99A5-4842F4C95D6A}"/>
               </a:ext>
             </a:extLst>
           </p:cNvPr>
@@ -9623,7 +9623,7 @@
     </p:spTree>
     <p:extLst>
       <p:ext uri="{BB962C8B-B14F-4D97-AF65-F5344CB8AC3E}">
-        <p14:creationId xmlns:p14="http://schemas.microsoft.com/office/powerpoint/2010/main" val="2060335775"/>
+        <p14:creationId xmlns:p14="http://schemas.microsoft.com/office/powerpoint/2010/main" val="2132090203"/>
       </p:ext>
     </p:extLst>
   </p:cSld>
@@ -9654,7 +9654,7 @@
           <p:cNvPr id="6" name="">
             <a:extLst xmlns:a="http://schemas.openxmlformats.org/drawingml/2006/main">
               <a:ext uri="{FF2B5EF4-FFF2-40B4-BE49-F238E27FC236}">
-                <a16:creationId xmlns:a16="http://schemas.microsoft.com/office/drawing/2014/main" id="{E4662D6A-6544-46EA-8F34-CE1E275AC614}"/>
+                <a16:creationId xmlns:a16="http://schemas.microsoft.com/office/drawing/2014/main" id="{33BF9E74-3D6A-49FF-ABCC-46264CEACB52}"/>
               </a:ext>
             </a:extLst>
           </p:cNvPr>
@@ -9711,7 +9711,7 @@
           <p:cNvPr id="2" name="">
             <a:extLst xmlns:a="http://schemas.openxmlformats.org/drawingml/2006/main">
               <a:ext uri="{FF2B5EF4-FFF2-40B4-BE49-F238E27FC236}">
-                <a16:creationId xmlns:a16="http://schemas.microsoft.com/office/drawing/2014/main" id="{F3B61BB1-2199-4DA4-8CA1-EE02CF4659A5}"/>
+                <a16:creationId xmlns:a16="http://schemas.microsoft.com/office/drawing/2014/main" id="{F2F79E7F-4506-4C22-9483-5DA802415C87}"/>
               </a:ext>
             </a:extLst>
           </p:cNvPr>
@@ -9775,7 +9775,7 @@
         </p:xfrm>
         <a:graphic xmlns:a="http://schemas.openxmlformats.org/drawingml/2006/main">
           <a:graphicData uri="http://schemas.openxmlformats.org/drawingml/2006/chart">
-            <c:chart xmlns:r="http://schemas.openxmlformats.org/officeDocument/2006/relationships" xmlns:c="http://schemas.openxmlformats.org/drawingml/2006/chart" r:id="R7e4e4e7382df4b2f"/>
+            <c:chart xmlns:r="http://schemas.openxmlformats.org/officeDocument/2006/relationships" xmlns:c="http://schemas.openxmlformats.org/drawingml/2006/chart" r:id="Ra35a04a8e42d4a17"/>
           </a:graphicData>
         </a:graphic>
       </p:graphicFrame>
@@ -9791,7 +9791,7 @@
         </p:xfrm>
         <a:graphic xmlns:a="http://schemas.openxmlformats.org/drawingml/2006/main">
           <a:graphicData uri="http://schemas.openxmlformats.org/drawingml/2006/chart">
-            <c:chart xmlns:r="http://schemas.openxmlformats.org/officeDocument/2006/relationships" xmlns:c="http://schemas.openxmlformats.org/drawingml/2006/chart" r:id="Rb97c0403727d479c"/>
+            <c:chart xmlns:r="http://schemas.openxmlformats.org/officeDocument/2006/relationships" xmlns:c="http://schemas.openxmlformats.org/drawingml/2006/chart" r:id="R93b73a83872848bf"/>
           </a:graphicData>
         </a:graphic>
       </p:graphicFrame>
@@ -9800,7 +9800,7 @@
           <p:cNvPr id="5" name="">
             <a:extLst xmlns:a="http://schemas.openxmlformats.org/drawingml/2006/main">
               <a:ext uri="{FF2B5EF4-FFF2-40B4-BE49-F238E27FC236}">
-                <a16:creationId xmlns:a16="http://schemas.microsoft.com/office/drawing/2014/main" id="{1639F5C3-F390-4DFA-B384-0BF873A78D6C}"/>
+                <a16:creationId xmlns:a16="http://schemas.microsoft.com/office/drawing/2014/main" id="{510B4609-896A-490E-A3ED-BF09DEBDE259}"/>
               </a:ext>
             </a:extLst>
           </p:cNvPr>
@@ -9855,7 +9855,7 @@
     </p:spTree>
     <p:extLst>
       <p:ext uri="{BB962C8B-B14F-4D97-AF65-F5344CB8AC3E}">
-        <p14:creationId xmlns:p14="http://schemas.microsoft.com/office/powerpoint/2010/main" val="1580040422"/>
+        <p14:creationId xmlns:p14="http://schemas.microsoft.com/office/powerpoint/2010/main" val="1134256439"/>
       </p:ext>
     </p:extLst>
   </p:cSld>
@@ -9886,7 +9886,7 @@
           <p:cNvPr id="5" name="">
             <a:extLst xmlns:a="http://schemas.openxmlformats.org/drawingml/2006/main">
               <a:ext uri="{FF2B5EF4-FFF2-40B4-BE49-F238E27FC236}">
-                <a16:creationId xmlns:a16="http://schemas.microsoft.com/office/drawing/2014/main" id="{606018E6-88E1-4162-B128-2C9E3F3C8BBC}"/>
+                <a16:creationId xmlns:a16="http://schemas.microsoft.com/office/drawing/2014/main" id="{B468ABA3-B6BD-4AAB-AF26-E1CA0152C747}"/>
               </a:ext>
             </a:extLst>
           </p:cNvPr>
@@ -9943,7 +9943,7 @@
           <p:cNvPr id="2" name="">
             <a:extLst xmlns:a="http://schemas.openxmlformats.org/drawingml/2006/main">
               <a:ext uri="{FF2B5EF4-FFF2-40B4-BE49-F238E27FC236}">
-                <a16:creationId xmlns:a16="http://schemas.microsoft.com/office/drawing/2014/main" id="{C6A5D4DE-E5E4-4BE7-93F5-877E06B66AE5}"/>
+                <a16:creationId xmlns:a16="http://schemas.microsoft.com/office/drawing/2014/main" id="{3629B14B-BD86-400C-8C26-5F334C088F88}"/>
               </a:ext>
             </a:extLst>
           </p:cNvPr>
@@ -10007,7 +10007,7 @@
         </p:xfrm>
         <a:graphic xmlns:a="http://schemas.openxmlformats.org/drawingml/2006/main">
           <a:graphicData uri="http://schemas.openxmlformats.org/drawingml/2006/chart">
-            <c:chart xmlns:r="http://schemas.openxmlformats.org/officeDocument/2006/relationships" xmlns:c="http://schemas.openxmlformats.org/drawingml/2006/chart" r:id="R7a5f7ead1c044bb4"/>
+            <c:chart xmlns:r="http://schemas.openxmlformats.org/officeDocument/2006/relationships" xmlns:c="http://schemas.openxmlformats.org/drawingml/2006/chart" r:id="Rb42a020e84ec4c10"/>
           </a:graphicData>
         </a:graphic>
       </p:graphicFrame>
@@ -10016,7 +10016,7 @@
           <p:cNvPr id="4" name="">
             <a:extLst xmlns:a="http://schemas.openxmlformats.org/drawingml/2006/main">
               <a:ext uri="{FF2B5EF4-FFF2-40B4-BE49-F238E27FC236}">
-                <a16:creationId xmlns:a16="http://schemas.microsoft.com/office/drawing/2014/main" id="{D87453BE-1771-4CC4-9BC1-713300A78F88}"/>
+                <a16:creationId xmlns:a16="http://schemas.microsoft.com/office/drawing/2014/main" id="{C151FE39-24EE-45FA-8F74-24BA4BAB5A7B}"/>
               </a:ext>
             </a:extLst>
           </p:cNvPr>
@@ -10071,7 +10071,7 @@
     </p:spTree>
     <p:extLst>
       <p:ext uri="{BB962C8B-B14F-4D97-AF65-F5344CB8AC3E}">
-        <p14:creationId xmlns:p14="http://schemas.microsoft.com/office/powerpoint/2010/main" val="1609250037"/>
+        <p14:creationId xmlns:p14="http://schemas.microsoft.com/office/powerpoint/2010/main" val="71315569"/>
       </p:ext>
     </p:extLst>
   </p:cSld>
@@ -10102,7 +10102,7 @@
           <p:cNvPr id="5" name="">
             <a:extLst xmlns:a="http://schemas.openxmlformats.org/drawingml/2006/main">
               <a:ext uri="{FF2B5EF4-FFF2-40B4-BE49-F238E27FC236}">
-                <a16:creationId xmlns:a16="http://schemas.microsoft.com/office/drawing/2014/main" id="{55CDBA57-EE7D-4093-8868-A7D5397266A0}"/>
+                <a16:creationId xmlns:a16="http://schemas.microsoft.com/office/drawing/2014/main" id="{4D538B60-926A-4564-91EC-F8394F72F0B5}"/>
               </a:ext>
             </a:extLst>
           </p:cNvPr>
@@ -10159,7 +10159,7 @@
           <p:cNvPr id="2" name="">
             <a:extLst xmlns:a="http://schemas.openxmlformats.org/drawingml/2006/main">
               <a:ext uri="{FF2B5EF4-FFF2-40B4-BE49-F238E27FC236}">
-                <a16:creationId xmlns:a16="http://schemas.microsoft.com/office/drawing/2014/main" id="{22B5BE9A-9F39-4DAE-AAC7-62497F640FE4}"/>
+                <a16:creationId xmlns:a16="http://schemas.microsoft.com/office/drawing/2014/main" id="{E7D90FB9-147E-4332-B434-84B8AD3A8638}"/>
               </a:ext>
             </a:extLst>
           </p:cNvPr>
@@ -10632,7 +10632,7 @@
           <p:cNvPr id="4" name="">
             <a:extLst xmlns:a="http://schemas.openxmlformats.org/drawingml/2006/main">
               <a:ext uri="{FF2B5EF4-FFF2-40B4-BE49-F238E27FC236}">
-                <a16:creationId xmlns:a16="http://schemas.microsoft.com/office/drawing/2014/main" id="{D3BBDB22-ADDB-4A60-8300-C2C0E16BD6FA}"/>
+                <a16:creationId xmlns:a16="http://schemas.microsoft.com/office/drawing/2014/main" id="{A7E6481F-944F-4C62-8961-5BE32CF38A8B}"/>
               </a:ext>
             </a:extLst>
           </p:cNvPr>
@@ -10687,7 +10687,7 @@
     </p:spTree>
     <p:extLst>
       <p:ext uri="{BB962C8B-B14F-4D97-AF65-F5344CB8AC3E}">
-        <p14:creationId xmlns:p14="http://schemas.microsoft.com/office/powerpoint/2010/main" val="2018077170"/>
+        <p14:creationId xmlns:p14="http://schemas.microsoft.com/office/powerpoint/2010/main" val="1082243086"/>
       </p:ext>
     </p:extLst>
   </p:cSld>

</xml_diff>